<commit_message>
docs: coste de la sesión en la presentación y el resumen
Tokens exactos del transcript de Claude Code (175 respuestas de
claude-opus-5-5) valorados a precios de API de Opus 5.5: ≈ 22,67 USD,
99 % de la entrada servida desde caché.

Co-Authored-By: Claude Opus 5.5 <noreply@anthropic.com>
</commit_message>
<xml_diff>
--- a/docs/presentacion/proxy-l7.pptx
+++ b/docs/presentacion/proxy-l7.pptx
@@ -8533,11 +8533,11 @@
             <a:avLst/>
           </a:prstGeom>
           <a:solidFill>
-            <a:srgbClr val="9A5B00"/>
+            <a:srgbClr val="0B6E69"/>
           </a:solidFill>
           <a:ln w="12700">
             <a:solidFill>
-              <a:srgbClr val="9A5B00"/>
+              <a:srgbClr val="0B6E69"/>
             </a:solidFill>
             <a:prstDash val="solid"/>
           </a:ln>
@@ -8576,7 +8576,7 @@
                 <a:ea typeface="Calibri" pitchFamily="34" charset="-122"/>
                 <a:cs typeface="Calibri" pitchFamily="34" charset="-120"/>
               </a:rPr>
-              <a:t>—</a:t>
+              <a:t>≈ $22,67</a:t>
             </a:r>
             <a:endParaRPr lang="en-US" sz="2800" dirty="0"/>
           </a:p>
@@ -8615,7 +8615,7 @@
                 <a:ea typeface="Calibri" pitchFamily="34" charset="-122"/>
                 <a:cs typeface="Calibri" pitchFamily="34" charset="-120"/>
               </a:rPr>
-              <a:t>coste USD · pendiente de /cost</a:t>
+              <a:t>USD, equivalente a precios de API</a:t>
             </a:r>
             <a:endParaRPr lang="en-US" sz="1200" dirty="0"/>
           </a:p>
@@ -8661,11 +8661,11 @@
             <a:avLst/>
           </a:prstGeom>
           <a:solidFill>
-            <a:srgbClr val="9A5B00"/>
+            <a:srgbClr val="0B6E69"/>
           </a:solidFill>
           <a:ln w="12700">
             <a:solidFill>
-              <a:srgbClr val="9A5B00"/>
+              <a:srgbClr val="0B6E69"/>
             </a:solidFill>
             <a:prstDash val="solid"/>
           </a:ln>
@@ -8704,7 +8704,7 @@
                 <a:ea typeface="Calibri" pitchFamily="34" charset="-122"/>
                 <a:cs typeface="Calibri" pitchFamily="34" charset="-120"/>
               </a:rPr>
-              <a:t>—</a:t>
+              <a:t>57,6 M</a:t>
             </a:r>
             <a:endParaRPr lang="en-US" sz="2800" dirty="0"/>
           </a:p>
@@ -8743,7 +8743,7 @@
                 <a:ea typeface="Calibri" pitchFamily="34" charset="-122"/>
                 <a:cs typeface="Calibri" pitchFamily="34" charset="-120"/>
               </a:rPr>
-              <a:t>tokens de entrada · pendiente de /cost</a:t>
+              <a:t>tokens de entrada (99 % desde caché)</a:t>
             </a:r>
             <a:endParaRPr lang="en-US" sz="1200" dirty="0"/>
           </a:p>
@@ -8789,11 +8789,11 @@
             <a:avLst/>
           </a:prstGeom>
           <a:solidFill>
-            <a:srgbClr val="9A5B00"/>
+            <a:srgbClr val="0B6E69"/>
           </a:solidFill>
           <a:ln w="12700">
             <a:solidFill>
-              <a:srgbClr val="9A5B00"/>
+              <a:srgbClr val="0B6E69"/>
             </a:solidFill>
             <a:prstDash val="solid"/>
           </a:ln>
@@ -8832,7 +8832,7 @@
                 <a:ea typeface="Calibri" pitchFamily="34" charset="-122"/>
                 <a:cs typeface="Calibri" pitchFamily="34" charset="-120"/>
               </a:rPr>
-              <a:t>—</a:t>
+              <a:t>376 k</a:t>
             </a:r>
             <a:endParaRPr lang="en-US" sz="2800" dirty="0"/>
           </a:p>
@@ -8871,7 +8871,7 @@
                 <a:ea typeface="Calibri" pitchFamily="34" charset="-122"/>
                 <a:cs typeface="Calibri" pitchFamily="34" charset="-120"/>
               </a:rPr>
-              <a:t>tokens de salida · pendiente de /cost</a:t>
+              <a:t>tokens de salida (código, docs y razonamiento)</a:t>
             </a:r>
             <a:endParaRPr lang="en-US" sz="1200" dirty="0"/>
           </a:p>
@@ -8917,11 +8917,11 @@
             <a:avLst/>
           </a:prstGeom>
           <a:solidFill>
-            <a:srgbClr val="9A5B00"/>
+            <a:srgbClr val="0B6E69"/>
           </a:solidFill>
           <a:ln w="12700">
             <a:solidFill>
-              <a:srgbClr val="9A5B00"/>
+              <a:srgbClr val="0B6E69"/>
             </a:solidFill>
             <a:prstDash val="solid"/>
           </a:ln>
@@ -8960,7 +8960,7 @@
                 <a:ea typeface="Calibri" pitchFamily="34" charset="-122"/>
                 <a:cs typeface="Calibri" pitchFamily="34" charset="-120"/>
               </a:rPr>
-              <a:t>—</a:t>
+              <a:t>2 h 09 min</a:t>
             </a:r>
             <a:endParaRPr lang="en-US" sz="2800" dirty="0"/>
           </a:p>
@@ -8999,48 +8999,9 @@
                 <a:ea typeface="Calibri" pitchFamily="34" charset="-122"/>
                 <a:cs typeface="Calibri" pitchFamily="34" charset="-120"/>
               </a:rPr>
-              <a:t>tiempo de API · pendiente de /cost</a:t>
+              <a:t>de sesión, de la spec al GitHub público</a:t>
             </a:r>
             <a:endParaRPr lang="en-US" sz="1200" dirty="0"/>
-          </a:p>
-        </p:txBody>
-      </p:sp>
-      <p:sp>
-        <p:nvSpPr>
-          <p:cNvPr id="20" name="Text 18"/>
-          <p:cNvSpPr/>
-          <p:nvPr/>
-        </p:nvSpPr>
-        <p:spPr>
-          <a:xfrm>
-            <a:off x="548640" y="3108960"/>
-            <a:ext cx="10972800" cy="411480"/>
-          </a:xfrm>
-          <a:prstGeom prst="rect">
-            <a:avLst/>
-          </a:prstGeom>
-          <a:noFill/>
-          <a:ln/>
-        </p:spPr>
-        <p:txBody>
-          <a:bodyPr wrap="square" rtlCol="0" anchor="ctr"/>
-          <a:lstStyle/>
-          <a:p>
-            <a:pPr indent="0" marL="0">
-              <a:buNone/>
-            </a:pPr>
-            <a:r>
-              <a:rPr lang="en-US" sz="1800" b="1" dirty="0">
-                <a:solidFill>
-                  <a:srgbClr val="1D2330"/>
-                </a:solidFill>
-                <a:latin typeface="Calibri" pitchFamily="34" charset="0"/>
-                <a:ea typeface="Calibri" pitchFamily="34" charset="-122"/>
-                <a:cs typeface="Calibri" pitchFamily="34" charset="-120"/>
-              </a:rPr>
-              <a:t>Esfuerzo medido en la sesión</a:t>
-            </a:r>
-            <a:endParaRPr lang="en-US" sz="1800" dirty="0"/>
           </a:p>
         </p:txBody>
       </p:sp>
@@ -9059,18 +9020,294 @@
           </p:nvPr>
         </p:nvGraphicFramePr>
         <p:xfrm>
-          <a:off x="548640" y="3566160"/>
-          <a:ext cx="11064240" cy="914400"/>
+          <a:off x="548640" y="3154680"/>
+          <a:ext cx="6766560" cy="914400"/>
         </p:xfrm>
         <a:graphic>
           <a:graphicData uri="http://schemas.openxmlformats.org/drawingml/2006/table">
             <a:tbl>
               <a:tblPr/>
               <a:tblGrid>
-                <a:gridCol w="5669280"/>
-                <a:gridCol w="5394960"/>
+                <a:gridCol w="3200400"/>
+                <a:gridCol w="1097280"/>
+                <a:gridCol w="1097280"/>
+                <a:gridCol w="1371600"/>
               </a:tblGrid>
-              <a:tr h="393192">
+              <a:tr h="384048">
+                <a:tc>
+                  <a:txBody>
+                    <a:bodyPr/>
+                    <a:lstStyle/>
+                    <a:p>
+                      <a:pPr algn="l" indent="0" marL="0">
+                        <a:buNone/>
+                      </a:pPr>
+                      <a:r>
+                        <a:rPr lang="en-US" sz="1300" b="1" dirty="0">
+                          <a:solidFill>
+                            <a:srgbClr val="1D2330"/>
+                          </a:solidFill>
+                          <a:latin typeface="Calibri" pitchFamily="34" charset="0"/>
+                          <a:ea typeface="Calibri" pitchFamily="34" charset="-122"/>
+                          <a:cs typeface="Calibri" pitchFamily="34" charset="-120"/>
+                        </a:rPr>
+                        <a:t>Concepto</a:t>
+                      </a:r>
+                      <a:endParaRPr lang="en-US" sz="1300" dirty="0">
+                        <a:latin typeface="Calibri" charset="0"/>
+                        <a:ea typeface="Calibri" charset="0"/>
+                        <a:cs typeface="Calibri" charset="0"/>
+                      </a:endParaRPr>
+                    </a:p>
+                  </a:txBody>
+                  <a:tcPr marL="91440" marR="91440" marT="45720" marB="45720">
+                    <a:lnL w="9525" cap="flat" cmpd="sng" algn="ctr">
+                      <a:solidFill>
+                        <a:srgbClr val="D9DEE7"/>
+                      </a:solidFill>
+                      <a:prstDash val="solid"/>
+                      <a:round/>
+                      <a:headEnd type="none" w="med" len="med"/>
+                      <a:tailEnd type="none" w="med" len="med"/>
+                    </a:lnL>
+                    <a:lnR w="9525" cap="flat" cmpd="sng" algn="ctr">
+                      <a:solidFill>
+                        <a:srgbClr val="D9DEE7"/>
+                      </a:solidFill>
+                      <a:prstDash val="solid"/>
+                      <a:round/>
+                      <a:headEnd type="none" w="med" len="med"/>
+                      <a:tailEnd type="none" w="med" len="med"/>
+                    </a:lnR>
+                    <a:lnT w="9525" cap="flat" cmpd="sng" algn="ctr">
+                      <a:solidFill>
+                        <a:srgbClr val="D9DEE7"/>
+                      </a:solidFill>
+                      <a:prstDash val="solid"/>
+                      <a:round/>
+                      <a:headEnd type="none" w="med" len="med"/>
+                      <a:tailEnd type="none" w="med" len="med"/>
+                    </a:lnT>
+                    <a:lnB w="9525" cap="flat" cmpd="sng" algn="ctr">
+                      <a:solidFill>
+                        <a:srgbClr val="D9DEE7"/>
+                      </a:solidFill>
+                      <a:prstDash val="solid"/>
+                      <a:round/>
+                      <a:headEnd type="none" w="med" len="med"/>
+                      <a:tailEnd type="none" w="med" len="med"/>
+                    </a:lnB>
+                    <a:solidFill>
+                      <a:srgbClr val="E6F2F1"/>
+                    </a:solidFill>
+                  </a:tcPr>
+                </a:tc>
+                <a:tc>
+                  <a:txBody>
+                    <a:bodyPr/>
+                    <a:lstStyle/>
+                    <a:p>
+                      <a:pPr algn="r" indent="0" marL="0">
+                        <a:buNone/>
+                      </a:pPr>
+                      <a:r>
+                        <a:rPr lang="en-US" sz="1300" b="1" dirty="0">
+                          <a:solidFill>
+                            <a:srgbClr val="1D2330"/>
+                          </a:solidFill>
+                          <a:latin typeface="Calibri" pitchFamily="34" charset="0"/>
+                          <a:ea typeface="Calibri" pitchFamily="34" charset="-122"/>
+                          <a:cs typeface="Calibri" pitchFamily="34" charset="-120"/>
+                        </a:rPr>
+                        <a:t>Tokens</a:t>
+                      </a:r>
+                      <a:endParaRPr lang="en-US" sz="1300" dirty="0">
+                        <a:latin typeface="Calibri" charset="0"/>
+                        <a:ea typeface="Calibri" charset="0"/>
+                        <a:cs typeface="Calibri" charset="0"/>
+                      </a:endParaRPr>
+                    </a:p>
+                  </a:txBody>
+                  <a:tcPr marL="91440" marR="91440" marT="45720" marB="45720">
+                    <a:lnL w="9525" cap="flat" cmpd="sng" algn="ctr">
+                      <a:solidFill>
+                        <a:srgbClr val="D9DEE7"/>
+                      </a:solidFill>
+                      <a:prstDash val="solid"/>
+                      <a:round/>
+                      <a:headEnd type="none" w="med" len="med"/>
+                      <a:tailEnd type="none" w="med" len="med"/>
+                    </a:lnL>
+                    <a:lnR w="9525" cap="flat" cmpd="sng" algn="ctr">
+                      <a:solidFill>
+                        <a:srgbClr val="D9DEE7"/>
+                      </a:solidFill>
+                      <a:prstDash val="solid"/>
+                      <a:round/>
+                      <a:headEnd type="none" w="med" len="med"/>
+                      <a:tailEnd type="none" w="med" len="med"/>
+                    </a:lnR>
+                    <a:lnT w="9525" cap="flat" cmpd="sng" algn="ctr">
+                      <a:solidFill>
+                        <a:srgbClr val="D9DEE7"/>
+                      </a:solidFill>
+                      <a:prstDash val="solid"/>
+                      <a:round/>
+                      <a:headEnd type="none" w="med" len="med"/>
+                      <a:tailEnd type="none" w="med" len="med"/>
+                    </a:lnT>
+                    <a:lnB w="9525" cap="flat" cmpd="sng" algn="ctr">
+                      <a:solidFill>
+                        <a:srgbClr val="D9DEE7"/>
+                      </a:solidFill>
+                      <a:prstDash val="solid"/>
+                      <a:round/>
+                      <a:headEnd type="none" w="med" len="med"/>
+                      <a:tailEnd type="none" w="med" len="med"/>
+                    </a:lnB>
+                    <a:solidFill>
+                      <a:srgbClr val="E6F2F1"/>
+                    </a:solidFill>
+                  </a:tcPr>
+                </a:tc>
+                <a:tc>
+                  <a:txBody>
+                    <a:bodyPr/>
+                    <a:lstStyle/>
+                    <a:p>
+                      <a:pPr algn="r" indent="0" marL="0">
+                        <a:buNone/>
+                      </a:pPr>
+                      <a:r>
+                        <a:rPr lang="en-US" sz="1300" b="1" dirty="0">
+                          <a:solidFill>
+                            <a:srgbClr val="1D2330"/>
+                          </a:solidFill>
+                          <a:latin typeface="Calibri" pitchFamily="34" charset="0"/>
+                          <a:ea typeface="Calibri" pitchFamily="34" charset="-122"/>
+                          <a:cs typeface="Calibri" pitchFamily="34" charset="-120"/>
+                        </a:rPr>
+                        <a:t>Precio</a:t>
+                      </a:r>
+                      <a:endParaRPr lang="en-US" sz="1300" dirty="0">
+                        <a:latin typeface="Calibri" charset="0"/>
+                        <a:ea typeface="Calibri" charset="0"/>
+                        <a:cs typeface="Calibri" charset="0"/>
+                      </a:endParaRPr>
+                    </a:p>
+                  </a:txBody>
+                  <a:tcPr marL="91440" marR="91440" marT="45720" marB="45720">
+                    <a:lnL w="9525" cap="flat" cmpd="sng" algn="ctr">
+                      <a:solidFill>
+                        <a:srgbClr val="D9DEE7"/>
+                      </a:solidFill>
+                      <a:prstDash val="solid"/>
+                      <a:round/>
+                      <a:headEnd type="none" w="med" len="med"/>
+                      <a:tailEnd type="none" w="med" len="med"/>
+                    </a:lnL>
+                    <a:lnR w="9525" cap="flat" cmpd="sng" algn="ctr">
+                      <a:solidFill>
+                        <a:srgbClr val="D9DEE7"/>
+                      </a:solidFill>
+                      <a:prstDash val="solid"/>
+                      <a:round/>
+                      <a:headEnd type="none" w="med" len="med"/>
+                      <a:tailEnd type="none" w="med" len="med"/>
+                    </a:lnR>
+                    <a:lnT w="9525" cap="flat" cmpd="sng" algn="ctr">
+                      <a:solidFill>
+                        <a:srgbClr val="D9DEE7"/>
+                      </a:solidFill>
+                      <a:prstDash val="solid"/>
+                      <a:round/>
+                      <a:headEnd type="none" w="med" len="med"/>
+                      <a:tailEnd type="none" w="med" len="med"/>
+                    </a:lnT>
+                    <a:lnB w="9525" cap="flat" cmpd="sng" algn="ctr">
+                      <a:solidFill>
+                        <a:srgbClr val="D9DEE7"/>
+                      </a:solidFill>
+                      <a:prstDash val="solid"/>
+                      <a:round/>
+                      <a:headEnd type="none" w="med" len="med"/>
+                      <a:tailEnd type="none" w="med" len="med"/>
+                    </a:lnB>
+                    <a:solidFill>
+                      <a:srgbClr val="E6F2F1"/>
+                    </a:solidFill>
+                  </a:tcPr>
+                </a:tc>
+                <a:tc>
+                  <a:txBody>
+                    <a:bodyPr/>
+                    <a:lstStyle/>
+                    <a:p>
+                      <a:pPr algn="r" indent="0" marL="0">
+                        <a:buNone/>
+                      </a:pPr>
+                      <a:r>
+                        <a:rPr lang="en-US" sz="1300" b="1" dirty="0">
+                          <a:solidFill>
+                            <a:srgbClr val="1D2330"/>
+                          </a:solidFill>
+                          <a:latin typeface="Calibri" pitchFamily="34" charset="0"/>
+                          <a:ea typeface="Calibri" pitchFamily="34" charset="-122"/>
+                          <a:cs typeface="Calibri" pitchFamily="34" charset="-120"/>
+                        </a:rPr>
+                        <a:t>USD</a:t>
+                      </a:r>
+                      <a:endParaRPr lang="en-US" sz="1300" dirty="0">
+                        <a:latin typeface="Calibri" charset="0"/>
+                        <a:ea typeface="Calibri" charset="0"/>
+                        <a:cs typeface="Calibri" charset="0"/>
+                      </a:endParaRPr>
+                    </a:p>
+                  </a:txBody>
+                  <a:tcPr marL="91440" marR="91440" marT="45720" marB="45720">
+                    <a:lnL w="9525" cap="flat" cmpd="sng" algn="ctr">
+                      <a:solidFill>
+                        <a:srgbClr val="D9DEE7"/>
+                      </a:solidFill>
+                      <a:prstDash val="solid"/>
+                      <a:round/>
+                      <a:headEnd type="none" w="med" len="med"/>
+                      <a:tailEnd type="none" w="med" len="med"/>
+                    </a:lnL>
+                    <a:lnR w="9525" cap="flat" cmpd="sng" algn="ctr">
+                      <a:solidFill>
+                        <a:srgbClr val="D9DEE7"/>
+                      </a:solidFill>
+                      <a:prstDash val="solid"/>
+                      <a:round/>
+                      <a:headEnd type="none" w="med" len="med"/>
+                      <a:tailEnd type="none" w="med" len="med"/>
+                    </a:lnR>
+                    <a:lnT w="9525" cap="flat" cmpd="sng" algn="ctr">
+                      <a:solidFill>
+                        <a:srgbClr val="D9DEE7"/>
+                      </a:solidFill>
+                      <a:prstDash val="solid"/>
+                      <a:round/>
+                      <a:headEnd type="none" w="med" len="med"/>
+                      <a:tailEnd type="none" w="med" len="med"/>
+                    </a:lnT>
+                    <a:lnB w="9525" cap="flat" cmpd="sng" algn="ctr">
+                      <a:solidFill>
+                        <a:srgbClr val="D9DEE7"/>
+                      </a:solidFill>
+                      <a:prstDash val="solid"/>
+                      <a:round/>
+                      <a:headEnd type="none" w="med" len="med"/>
+                      <a:tailEnd type="none" w="med" len="med"/>
+                    </a:lnB>
+                    <a:solidFill>
+                      <a:srgbClr val="E6F2F1"/>
+                    </a:solidFill>
+                  </a:tcPr>
+                </a:tc>
+              </a:tr>
+              <a:tr h="384048">
                 <a:tc>
                   <a:txBody>
                     <a:bodyPr/>
@@ -9080,7 +9317,7 @@
                         <a:buNone/>
                       </a:pPr>
                       <a:r>
-                        <a:rPr lang="en-US" sz="1350" dirty="0">
+                        <a:rPr lang="en-US" sz="1300" dirty="0">
                           <a:solidFill>
                             <a:srgbClr val="1D2330"/>
                           </a:solidFill>
@@ -9088,9 +9325,795 @@
                           <a:ea typeface="Calibri" pitchFamily="34" charset="-122"/>
                           <a:cs typeface="Calibri" pitchFamily="34" charset="-120"/>
                         </a:rPr>
-                        <a:t>Tiempo total de la sesión (spec → MR → documentación)</a:t>
+                        <a:t>Lectura de caché (contexto reutilizado)</a:t>
                       </a:r>
-                      <a:endParaRPr lang="en-US" sz="1350" dirty="0">
+                      <a:endParaRPr lang="en-US" sz="1300" dirty="0">
+                        <a:latin typeface="Calibri" charset="0"/>
+                        <a:ea typeface="Calibri" charset="0"/>
+                        <a:cs typeface="Calibri" charset="0"/>
+                      </a:endParaRPr>
+                    </a:p>
+                  </a:txBody>
+                  <a:tcPr marL="91440" marR="91440" marT="45720" marB="45720">
+                    <a:lnL w="9525" cap="flat" cmpd="sng" algn="ctr">
+                      <a:solidFill>
+                        <a:srgbClr val="D9DEE7"/>
+                      </a:solidFill>
+                      <a:prstDash val="solid"/>
+                      <a:round/>
+                      <a:headEnd type="none" w="med" len="med"/>
+                      <a:tailEnd type="none" w="med" len="med"/>
+                    </a:lnL>
+                    <a:lnR w="9525" cap="flat" cmpd="sng" algn="ctr">
+                      <a:solidFill>
+                        <a:srgbClr val="D9DEE7"/>
+                      </a:solidFill>
+                      <a:prstDash val="solid"/>
+                      <a:round/>
+                      <a:headEnd type="none" w="med" len="med"/>
+                      <a:tailEnd type="none" w="med" len="med"/>
+                    </a:lnR>
+                    <a:lnT w="9525" cap="flat" cmpd="sng" algn="ctr">
+                      <a:solidFill>
+                        <a:srgbClr val="D9DEE7"/>
+                      </a:solidFill>
+                      <a:prstDash val="solid"/>
+                      <a:round/>
+                      <a:headEnd type="none" w="med" len="med"/>
+                      <a:tailEnd type="none" w="med" len="med"/>
+                    </a:lnT>
+                    <a:lnB w="9525" cap="flat" cmpd="sng" algn="ctr">
+                      <a:solidFill>
+                        <a:srgbClr val="D9DEE7"/>
+                      </a:solidFill>
+                      <a:prstDash val="solid"/>
+                      <a:round/>
+                      <a:headEnd type="none" w="med" len="med"/>
+                      <a:tailEnd type="none" w="med" len="med"/>
+                    </a:lnB>
+                  </a:tcPr>
+                </a:tc>
+                <a:tc>
+                  <a:txBody>
+                    <a:bodyPr/>
+                    <a:lstStyle/>
+                    <a:p>
+                      <a:pPr algn="r" indent="0" marL="0">
+                        <a:buNone/>
+                      </a:pPr>
+                      <a:r>
+                        <a:rPr lang="en-US" sz="1300" dirty="0">
+                          <a:solidFill>
+                            <a:srgbClr val="1D2330"/>
+                          </a:solidFill>
+                          <a:latin typeface="Calibri" pitchFamily="34" charset="0"/>
+                          <a:ea typeface="Calibri" pitchFamily="34" charset="-122"/>
+                          <a:cs typeface="Calibri" pitchFamily="34" charset="-120"/>
+                        </a:rPr>
+                        <a:t>57,2 M</a:t>
+                      </a:r>
+                      <a:endParaRPr lang="en-US" sz="1300" dirty="0">
+                        <a:latin typeface="Calibri" charset="0"/>
+                        <a:ea typeface="Calibri" charset="0"/>
+                        <a:cs typeface="Calibri" charset="0"/>
+                      </a:endParaRPr>
+                    </a:p>
+                  </a:txBody>
+                  <a:tcPr marL="91440" marR="91440" marT="45720" marB="45720">
+                    <a:lnL w="9525" cap="flat" cmpd="sng" algn="ctr">
+                      <a:solidFill>
+                        <a:srgbClr val="D9DEE7"/>
+                      </a:solidFill>
+                      <a:prstDash val="solid"/>
+                      <a:round/>
+                      <a:headEnd type="none" w="med" len="med"/>
+                      <a:tailEnd type="none" w="med" len="med"/>
+                    </a:lnL>
+                    <a:lnR w="9525" cap="flat" cmpd="sng" algn="ctr">
+                      <a:solidFill>
+                        <a:srgbClr val="D9DEE7"/>
+                      </a:solidFill>
+                      <a:prstDash val="solid"/>
+                      <a:round/>
+                      <a:headEnd type="none" w="med" len="med"/>
+                      <a:tailEnd type="none" w="med" len="med"/>
+                    </a:lnR>
+                    <a:lnT w="9525" cap="flat" cmpd="sng" algn="ctr">
+                      <a:solidFill>
+                        <a:srgbClr val="D9DEE7"/>
+                      </a:solidFill>
+                      <a:prstDash val="solid"/>
+                      <a:round/>
+                      <a:headEnd type="none" w="med" len="med"/>
+                      <a:tailEnd type="none" w="med" len="med"/>
+                    </a:lnT>
+                    <a:lnB w="9525" cap="flat" cmpd="sng" algn="ctr">
+                      <a:solidFill>
+                        <a:srgbClr val="D9DEE7"/>
+                      </a:solidFill>
+                      <a:prstDash val="solid"/>
+                      <a:round/>
+                      <a:headEnd type="none" w="med" len="med"/>
+                      <a:tailEnd type="none" w="med" len="med"/>
+                    </a:lnB>
+                  </a:tcPr>
+                </a:tc>
+                <a:tc>
+                  <a:txBody>
+                    <a:bodyPr/>
+                    <a:lstStyle/>
+                    <a:p>
+                      <a:pPr algn="r" indent="0" marL="0">
+                        <a:buNone/>
+                      </a:pPr>
+                      <a:r>
+                        <a:rPr lang="en-US" sz="1300" dirty="0">
+                          <a:solidFill>
+                            <a:srgbClr val="5B6475"/>
+                          </a:solidFill>
+                          <a:latin typeface="Calibri" pitchFamily="34" charset="0"/>
+                          <a:ea typeface="Calibri" pitchFamily="34" charset="-122"/>
+                          <a:cs typeface="Calibri" pitchFamily="34" charset="-120"/>
+                        </a:rPr>
+                        <a:t>$0,20/M</a:t>
+                      </a:r>
+                      <a:endParaRPr lang="en-US" sz="1300" dirty="0">
+                        <a:latin typeface="Calibri" charset="0"/>
+                        <a:ea typeface="Calibri" charset="0"/>
+                        <a:cs typeface="Calibri" charset="0"/>
+                      </a:endParaRPr>
+                    </a:p>
+                  </a:txBody>
+                  <a:tcPr marL="91440" marR="91440" marT="45720" marB="45720">
+                    <a:lnL w="9525" cap="flat" cmpd="sng" algn="ctr">
+                      <a:solidFill>
+                        <a:srgbClr val="D9DEE7"/>
+                      </a:solidFill>
+                      <a:prstDash val="solid"/>
+                      <a:round/>
+                      <a:headEnd type="none" w="med" len="med"/>
+                      <a:tailEnd type="none" w="med" len="med"/>
+                    </a:lnL>
+                    <a:lnR w="9525" cap="flat" cmpd="sng" algn="ctr">
+                      <a:solidFill>
+                        <a:srgbClr val="D9DEE7"/>
+                      </a:solidFill>
+                      <a:prstDash val="solid"/>
+                      <a:round/>
+                      <a:headEnd type="none" w="med" len="med"/>
+                      <a:tailEnd type="none" w="med" len="med"/>
+                    </a:lnR>
+                    <a:lnT w="9525" cap="flat" cmpd="sng" algn="ctr">
+                      <a:solidFill>
+                        <a:srgbClr val="D9DEE7"/>
+                      </a:solidFill>
+                      <a:prstDash val="solid"/>
+                      <a:round/>
+                      <a:headEnd type="none" w="med" len="med"/>
+                      <a:tailEnd type="none" w="med" len="med"/>
+                    </a:lnT>
+                    <a:lnB w="9525" cap="flat" cmpd="sng" algn="ctr">
+                      <a:solidFill>
+                        <a:srgbClr val="D9DEE7"/>
+                      </a:solidFill>
+                      <a:prstDash val="solid"/>
+                      <a:round/>
+                      <a:headEnd type="none" w="med" len="med"/>
+                      <a:tailEnd type="none" w="med" len="med"/>
+                    </a:lnB>
+                  </a:tcPr>
+                </a:tc>
+                <a:tc>
+                  <a:txBody>
+                    <a:bodyPr/>
+                    <a:lstStyle/>
+                    <a:p>
+                      <a:pPr algn="r" indent="0" marL="0">
+                        <a:buNone/>
+                      </a:pPr>
+                      <a:r>
+                        <a:rPr lang="en-US" sz="1300" b="1" dirty="0">
+                          <a:solidFill>
+                            <a:srgbClr val="1D2330"/>
+                          </a:solidFill>
+                          <a:latin typeface="Calibri" pitchFamily="34" charset="0"/>
+                          <a:ea typeface="Calibri" pitchFamily="34" charset="-122"/>
+                          <a:cs typeface="Calibri" pitchFamily="34" charset="-120"/>
+                        </a:rPr>
+                        <a:t>$11,44</a:t>
+                      </a:r>
+                      <a:endParaRPr lang="en-US" sz="1300" dirty="0">
+                        <a:latin typeface="Calibri" charset="0"/>
+                        <a:ea typeface="Calibri" charset="0"/>
+                        <a:cs typeface="Calibri" charset="0"/>
+                      </a:endParaRPr>
+                    </a:p>
+                  </a:txBody>
+                  <a:tcPr marL="91440" marR="91440" marT="45720" marB="45720">
+                    <a:lnL w="9525" cap="flat" cmpd="sng" algn="ctr">
+                      <a:solidFill>
+                        <a:srgbClr val="D9DEE7"/>
+                      </a:solidFill>
+                      <a:prstDash val="solid"/>
+                      <a:round/>
+                      <a:headEnd type="none" w="med" len="med"/>
+                      <a:tailEnd type="none" w="med" len="med"/>
+                    </a:lnL>
+                    <a:lnR w="9525" cap="flat" cmpd="sng" algn="ctr">
+                      <a:solidFill>
+                        <a:srgbClr val="D9DEE7"/>
+                      </a:solidFill>
+                      <a:prstDash val="solid"/>
+                      <a:round/>
+                      <a:headEnd type="none" w="med" len="med"/>
+                      <a:tailEnd type="none" w="med" len="med"/>
+                    </a:lnR>
+                    <a:lnT w="9525" cap="flat" cmpd="sng" algn="ctr">
+                      <a:solidFill>
+                        <a:srgbClr val="D9DEE7"/>
+                      </a:solidFill>
+                      <a:prstDash val="solid"/>
+                      <a:round/>
+                      <a:headEnd type="none" w="med" len="med"/>
+                      <a:tailEnd type="none" w="med" len="med"/>
+                    </a:lnT>
+                    <a:lnB w="9525" cap="flat" cmpd="sng" algn="ctr">
+                      <a:solidFill>
+                        <a:srgbClr val="D9DEE7"/>
+                      </a:solidFill>
+                      <a:prstDash val="solid"/>
+                      <a:round/>
+                      <a:headEnd type="none" w="med" len="med"/>
+                      <a:tailEnd type="none" w="med" len="med"/>
+                    </a:lnB>
+                  </a:tcPr>
+                </a:tc>
+              </a:tr>
+              <a:tr h="384048">
+                <a:tc>
+                  <a:txBody>
+                    <a:bodyPr/>
+                    <a:lstStyle/>
+                    <a:p>
+                      <a:pPr indent="0" marL="0">
+                        <a:buNone/>
+                      </a:pPr>
+                      <a:r>
+                        <a:rPr lang="en-US" sz="1300" dirty="0">
+                          <a:solidFill>
+                            <a:srgbClr val="1D2330"/>
+                          </a:solidFill>
+                          <a:latin typeface="Calibri" pitchFamily="34" charset="0"/>
+                          <a:ea typeface="Calibri" pitchFamily="34" charset="-122"/>
+                          <a:cs typeface="Calibri" pitchFamily="34" charset="-120"/>
+                        </a:rPr>
+                        <a:t>Salida generada</a:t>
+                      </a:r>
+                      <a:endParaRPr lang="en-US" sz="1300" dirty="0">
+                        <a:latin typeface="Calibri" charset="0"/>
+                        <a:ea typeface="Calibri" charset="0"/>
+                        <a:cs typeface="Calibri" charset="0"/>
+                      </a:endParaRPr>
+                    </a:p>
+                  </a:txBody>
+                  <a:tcPr marL="91440" marR="91440" marT="45720" marB="45720">
+                    <a:lnL w="9525" cap="flat" cmpd="sng" algn="ctr">
+                      <a:solidFill>
+                        <a:srgbClr val="D9DEE7"/>
+                      </a:solidFill>
+                      <a:prstDash val="solid"/>
+                      <a:round/>
+                      <a:headEnd type="none" w="med" len="med"/>
+                      <a:tailEnd type="none" w="med" len="med"/>
+                    </a:lnL>
+                    <a:lnR w="9525" cap="flat" cmpd="sng" algn="ctr">
+                      <a:solidFill>
+                        <a:srgbClr val="D9DEE7"/>
+                      </a:solidFill>
+                      <a:prstDash val="solid"/>
+                      <a:round/>
+                      <a:headEnd type="none" w="med" len="med"/>
+                      <a:tailEnd type="none" w="med" len="med"/>
+                    </a:lnR>
+                    <a:lnT w="9525" cap="flat" cmpd="sng" algn="ctr">
+                      <a:solidFill>
+                        <a:srgbClr val="D9DEE7"/>
+                      </a:solidFill>
+                      <a:prstDash val="solid"/>
+                      <a:round/>
+                      <a:headEnd type="none" w="med" len="med"/>
+                      <a:tailEnd type="none" w="med" len="med"/>
+                    </a:lnT>
+                    <a:lnB w="9525" cap="flat" cmpd="sng" algn="ctr">
+                      <a:solidFill>
+                        <a:srgbClr val="D9DEE7"/>
+                      </a:solidFill>
+                      <a:prstDash val="solid"/>
+                      <a:round/>
+                      <a:headEnd type="none" w="med" len="med"/>
+                      <a:tailEnd type="none" w="med" len="med"/>
+                    </a:lnB>
+                  </a:tcPr>
+                </a:tc>
+                <a:tc>
+                  <a:txBody>
+                    <a:bodyPr/>
+                    <a:lstStyle/>
+                    <a:p>
+                      <a:pPr algn="r" indent="0" marL="0">
+                        <a:buNone/>
+                      </a:pPr>
+                      <a:r>
+                        <a:rPr lang="en-US" sz="1300" dirty="0">
+                          <a:solidFill>
+                            <a:srgbClr val="1D2330"/>
+                          </a:solidFill>
+                          <a:latin typeface="Calibri" pitchFamily="34" charset="0"/>
+                          <a:ea typeface="Calibri" pitchFamily="34" charset="-122"/>
+                          <a:cs typeface="Calibri" pitchFamily="34" charset="-120"/>
+                        </a:rPr>
+                        <a:t>376 k</a:t>
+                      </a:r>
+                      <a:endParaRPr lang="en-US" sz="1300" dirty="0">
+                        <a:latin typeface="Calibri" charset="0"/>
+                        <a:ea typeface="Calibri" charset="0"/>
+                        <a:cs typeface="Calibri" charset="0"/>
+                      </a:endParaRPr>
+                    </a:p>
+                  </a:txBody>
+                  <a:tcPr marL="91440" marR="91440" marT="45720" marB="45720">
+                    <a:lnL w="9525" cap="flat" cmpd="sng" algn="ctr">
+                      <a:solidFill>
+                        <a:srgbClr val="D9DEE7"/>
+                      </a:solidFill>
+                      <a:prstDash val="solid"/>
+                      <a:round/>
+                      <a:headEnd type="none" w="med" len="med"/>
+                      <a:tailEnd type="none" w="med" len="med"/>
+                    </a:lnL>
+                    <a:lnR w="9525" cap="flat" cmpd="sng" algn="ctr">
+                      <a:solidFill>
+                        <a:srgbClr val="D9DEE7"/>
+                      </a:solidFill>
+                      <a:prstDash val="solid"/>
+                      <a:round/>
+                      <a:headEnd type="none" w="med" len="med"/>
+                      <a:tailEnd type="none" w="med" len="med"/>
+                    </a:lnR>
+                    <a:lnT w="9525" cap="flat" cmpd="sng" algn="ctr">
+                      <a:solidFill>
+                        <a:srgbClr val="D9DEE7"/>
+                      </a:solidFill>
+                      <a:prstDash val="solid"/>
+                      <a:round/>
+                      <a:headEnd type="none" w="med" len="med"/>
+                      <a:tailEnd type="none" w="med" len="med"/>
+                    </a:lnT>
+                    <a:lnB w="9525" cap="flat" cmpd="sng" algn="ctr">
+                      <a:solidFill>
+                        <a:srgbClr val="D9DEE7"/>
+                      </a:solidFill>
+                      <a:prstDash val="solid"/>
+                      <a:round/>
+                      <a:headEnd type="none" w="med" len="med"/>
+                      <a:tailEnd type="none" w="med" len="med"/>
+                    </a:lnB>
+                  </a:tcPr>
+                </a:tc>
+                <a:tc>
+                  <a:txBody>
+                    <a:bodyPr/>
+                    <a:lstStyle/>
+                    <a:p>
+                      <a:pPr algn="r" indent="0" marL="0">
+                        <a:buNone/>
+                      </a:pPr>
+                      <a:r>
+                        <a:rPr lang="en-US" sz="1300" dirty="0">
+                          <a:solidFill>
+                            <a:srgbClr val="5B6475"/>
+                          </a:solidFill>
+                          <a:latin typeface="Calibri" pitchFamily="34" charset="0"/>
+                          <a:ea typeface="Calibri" pitchFamily="34" charset="-122"/>
+                          <a:cs typeface="Calibri" pitchFamily="34" charset="-120"/>
+                        </a:rPr>
+                        <a:t>$20,00/M</a:t>
+                      </a:r>
+                      <a:endParaRPr lang="en-US" sz="1300" dirty="0">
+                        <a:latin typeface="Calibri" charset="0"/>
+                        <a:ea typeface="Calibri" charset="0"/>
+                        <a:cs typeface="Calibri" charset="0"/>
+                      </a:endParaRPr>
+                    </a:p>
+                  </a:txBody>
+                  <a:tcPr marL="91440" marR="91440" marT="45720" marB="45720">
+                    <a:lnL w="9525" cap="flat" cmpd="sng" algn="ctr">
+                      <a:solidFill>
+                        <a:srgbClr val="D9DEE7"/>
+                      </a:solidFill>
+                      <a:prstDash val="solid"/>
+                      <a:round/>
+                      <a:headEnd type="none" w="med" len="med"/>
+                      <a:tailEnd type="none" w="med" len="med"/>
+                    </a:lnL>
+                    <a:lnR w="9525" cap="flat" cmpd="sng" algn="ctr">
+                      <a:solidFill>
+                        <a:srgbClr val="D9DEE7"/>
+                      </a:solidFill>
+                      <a:prstDash val="solid"/>
+                      <a:round/>
+                      <a:headEnd type="none" w="med" len="med"/>
+                      <a:tailEnd type="none" w="med" len="med"/>
+                    </a:lnR>
+                    <a:lnT w="9525" cap="flat" cmpd="sng" algn="ctr">
+                      <a:solidFill>
+                        <a:srgbClr val="D9DEE7"/>
+                      </a:solidFill>
+                      <a:prstDash val="solid"/>
+                      <a:round/>
+                      <a:headEnd type="none" w="med" len="med"/>
+                      <a:tailEnd type="none" w="med" len="med"/>
+                    </a:lnT>
+                    <a:lnB w="9525" cap="flat" cmpd="sng" algn="ctr">
+                      <a:solidFill>
+                        <a:srgbClr val="D9DEE7"/>
+                      </a:solidFill>
+                      <a:prstDash val="solid"/>
+                      <a:round/>
+                      <a:headEnd type="none" w="med" len="med"/>
+                      <a:tailEnd type="none" w="med" len="med"/>
+                    </a:lnB>
+                  </a:tcPr>
+                </a:tc>
+                <a:tc>
+                  <a:txBody>
+                    <a:bodyPr/>
+                    <a:lstStyle/>
+                    <a:p>
+                      <a:pPr algn="r" indent="0" marL="0">
+                        <a:buNone/>
+                      </a:pPr>
+                      <a:r>
+                        <a:rPr lang="en-US" sz="1300" b="1" dirty="0">
+                          <a:solidFill>
+                            <a:srgbClr val="1D2330"/>
+                          </a:solidFill>
+                          <a:latin typeface="Calibri" pitchFamily="34" charset="0"/>
+                          <a:ea typeface="Calibri" pitchFamily="34" charset="-122"/>
+                          <a:cs typeface="Calibri" pitchFamily="34" charset="-120"/>
+                        </a:rPr>
+                        <a:t>$7,52</a:t>
+                      </a:r>
+                      <a:endParaRPr lang="en-US" sz="1300" dirty="0">
+                        <a:latin typeface="Calibri" charset="0"/>
+                        <a:ea typeface="Calibri" charset="0"/>
+                        <a:cs typeface="Calibri" charset="0"/>
+                      </a:endParaRPr>
+                    </a:p>
+                  </a:txBody>
+                  <a:tcPr marL="91440" marR="91440" marT="45720" marB="45720">
+                    <a:lnL w="9525" cap="flat" cmpd="sng" algn="ctr">
+                      <a:solidFill>
+                        <a:srgbClr val="D9DEE7"/>
+                      </a:solidFill>
+                      <a:prstDash val="solid"/>
+                      <a:round/>
+                      <a:headEnd type="none" w="med" len="med"/>
+                      <a:tailEnd type="none" w="med" len="med"/>
+                    </a:lnL>
+                    <a:lnR w="9525" cap="flat" cmpd="sng" algn="ctr">
+                      <a:solidFill>
+                        <a:srgbClr val="D9DEE7"/>
+                      </a:solidFill>
+                      <a:prstDash val="solid"/>
+                      <a:round/>
+                      <a:headEnd type="none" w="med" len="med"/>
+                      <a:tailEnd type="none" w="med" len="med"/>
+                    </a:lnR>
+                    <a:lnT w="9525" cap="flat" cmpd="sng" algn="ctr">
+                      <a:solidFill>
+                        <a:srgbClr val="D9DEE7"/>
+                      </a:solidFill>
+                      <a:prstDash val="solid"/>
+                      <a:round/>
+                      <a:headEnd type="none" w="med" len="med"/>
+                      <a:tailEnd type="none" w="med" len="med"/>
+                    </a:lnT>
+                    <a:lnB w="9525" cap="flat" cmpd="sng" algn="ctr">
+                      <a:solidFill>
+                        <a:srgbClr val="D9DEE7"/>
+                      </a:solidFill>
+                      <a:prstDash val="solid"/>
+                      <a:round/>
+                      <a:headEnd type="none" w="med" len="med"/>
+                      <a:tailEnd type="none" w="med" len="med"/>
+                    </a:lnB>
+                  </a:tcPr>
+                </a:tc>
+              </a:tr>
+              <a:tr h="384048">
+                <a:tc>
+                  <a:txBody>
+                    <a:bodyPr/>
+                    <a:lstStyle/>
+                    <a:p>
+                      <a:pPr indent="0" marL="0">
+                        <a:buNone/>
+                      </a:pPr>
+                      <a:r>
+                        <a:rPr lang="en-US" sz="1300" dirty="0">
+                          <a:solidFill>
+                            <a:srgbClr val="1D2330"/>
+                          </a:solidFill>
+                          <a:latin typeface="Calibri" pitchFamily="34" charset="0"/>
+                          <a:ea typeface="Calibri" pitchFamily="34" charset="-122"/>
+                          <a:cs typeface="Calibri" pitchFamily="34" charset="-120"/>
+                        </a:rPr>
+                        <a:t>Escritura de caché (TTL 1 h)</a:t>
+                      </a:r>
+                      <a:endParaRPr lang="en-US" sz="1300" dirty="0">
+                        <a:latin typeface="Calibri" charset="0"/>
+                        <a:ea typeface="Calibri" charset="0"/>
+                        <a:cs typeface="Calibri" charset="0"/>
+                      </a:endParaRPr>
+                    </a:p>
+                  </a:txBody>
+                  <a:tcPr marL="91440" marR="91440" marT="45720" marB="45720">
+                    <a:lnL w="9525" cap="flat" cmpd="sng" algn="ctr">
+                      <a:solidFill>
+                        <a:srgbClr val="D9DEE7"/>
+                      </a:solidFill>
+                      <a:prstDash val="solid"/>
+                      <a:round/>
+                      <a:headEnd type="none" w="med" len="med"/>
+                      <a:tailEnd type="none" w="med" len="med"/>
+                    </a:lnL>
+                    <a:lnR w="9525" cap="flat" cmpd="sng" algn="ctr">
+                      <a:solidFill>
+                        <a:srgbClr val="D9DEE7"/>
+                      </a:solidFill>
+                      <a:prstDash val="solid"/>
+                      <a:round/>
+                      <a:headEnd type="none" w="med" len="med"/>
+                      <a:tailEnd type="none" w="med" len="med"/>
+                    </a:lnR>
+                    <a:lnT w="9525" cap="flat" cmpd="sng" algn="ctr">
+                      <a:solidFill>
+                        <a:srgbClr val="D9DEE7"/>
+                      </a:solidFill>
+                      <a:prstDash val="solid"/>
+                      <a:round/>
+                      <a:headEnd type="none" w="med" len="med"/>
+                      <a:tailEnd type="none" w="med" len="med"/>
+                    </a:lnT>
+                    <a:lnB w="9525" cap="flat" cmpd="sng" algn="ctr">
+                      <a:solidFill>
+                        <a:srgbClr val="D9DEE7"/>
+                      </a:solidFill>
+                      <a:prstDash val="solid"/>
+                      <a:round/>
+                      <a:headEnd type="none" w="med" len="med"/>
+                      <a:tailEnd type="none" w="med" len="med"/>
+                    </a:lnB>
+                  </a:tcPr>
+                </a:tc>
+                <a:tc>
+                  <a:txBody>
+                    <a:bodyPr/>
+                    <a:lstStyle/>
+                    <a:p>
+                      <a:pPr algn="r" indent="0" marL="0">
+                        <a:buNone/>
+                      </a:pPr>
+                      <a:r>
+                        <a:rPr lang="en-US" sz="1300" dirty="0">
+                          <a:solidFill>
+                            <a:srgbClr val="1D2330"/>
+                          </a:solidFill>
+                          <a:latin typeface="Calibri" pitchFamily="34" charset="0"/>
+                          <a:ea typeface="Calibri" pitchFamily="34" charset="-122"/>
+                          <a:cs typeface="Calibri" pitchFamily="34" charset="-120"/>
+                        </a:rPr>
+                        <a:t>464 k</a:t>
+                      </a:r>
+                      <a:endParaRPr lang="en-US" sz="1300" dirty="0">
+                        <a:latin typeface="Calibri" charset="0"/>
+                        <a:ea typeface="Calibri" charset="0"/>
+                        <a:cs typeface="Calibri" charset="0"/>
+                      </a:endParaRPr>
+                    </a:p>
+                  </a:txBody>
+                  <a:tcPr marL="91440" marR="91440" marT="45720" marB="45720">
+                    <a:lnL w="9525" cap="flat" cmpd="sng" algn="ctr">
+                      <a:solidFill>
+                        <a:srgbClr val="D9DEE7"/>
+                      </a:solidFill>
+                      <a:prstDash val="solid"/>
+                      <a:round/>
+                      <a:headEnd type="none" w="med" len="med"/>
+                      <a:tailEnd type="none" w="med" len="med"/>
+                    </a:lnL>
+                    <a:lnR w="9525" cap="flat" cmpd="sng" algn="ctr">
+                      <a:solidFill>
+                        <a:srgbClr val="D9DEE7"/>
+                      </a:solidFill>
+                      <a:prstDash val="solid"/>
+                      <a:round/>
+                      <a:headEnd type="none" w="med" len="med"/>
+                      <a:tailEnd type="none" w="med" len="med"/>
+                    </a:lnR>
+                    <a:lnT w="9525" cap="flat" cmpd="sng" algn="ctr">
+                      <a:solidFill>
+                        <a:srgbClr val="D9DEE7"/>
+                      </a:solidFill>
+                      <a:prstDash val="solid"/>
+                      <a:round/>
+                      <a:headEnd type="none" w="med" len="med"/>
+                      <a:tailEnd type="none" w="med" len="med"/>
+                    </a:lnT>
+                    <a:lnB w="9525" cap="flat" cmpd="sng" algn="ctr">
+                      <a:solidFill>
+                        <a:srgbClr val="D9DEE7"/>
+                      </a:solidFill>
+                      <a:prstDash val="solid"/>
+                      <a:round/>
+                      <a:headEnd type="none" w="med" len="med"/>
+                      <a:tailEnd type="none" w="med" len="med"/>
+                    </a:lnB>
+                  </a:tcPr>
+                </a:tc>
+                <a:tc>
+                  <a:txBody>
+                    <a:bodyPr/>
+                    <a:lstStyle/>
+                    <a:p>
+                      <a:pPr algn="r" indent="0" marL="0">
+                        <a:buNone/>
+                      </a:pPr>
+                      <a:r>
+                        <a:rPr lang="en-US" sz="1300" dirty="0">
+                          <a:solidFill>
+                            <a:srgbClr val="5B6475"/>
+                          </a:solidFill>
+                          <a:latin typeface="Calibri" pitchFamily="34" charset="0"/>
+                          <a:ea typeface="Calibri" pitchFamily="34" charset="-122"/>
+                          <a:cs typeface="Calibri" pitchFamily="34" charset="-120"/>
+                        </a:rPr>
+                        <a:t>$8,00/M</a:t>
+                      </a:r>
+                      <a:endParaRPr lang="en-US" sz="1300" dirty="0">
+                        <a:latin typeface="Calibri" charset="0"/>
+                        <a:ea typeface="Calibri" charset="0"/>
+                        <a:cs typeface="Calibri" charset="0"/>
+                      </a:endParaRPr>
+                    </a:p>
+                  </a:txBody>
+                  <a:tcPr marL="91440" marR="91440" marT="45720" marB="45720">
+                    <a:lnL w="9525" cap="flat" cmpd="sng" algn="ctr">
+                      <a:solidFill>
+                        <a:srgbClr val="D9DEE7"/>
+                      </a:solidFill>
+                      <a:prstDash val="solid"/>
+                      <a:round/>
+                      <a:headEnd type="none" w="med" len="med"/>
+                      <a:tailEnd type="none" w="med" len="med"/>
+                    </a:lnL>
+                    <a:lnR w="9525" cap="flat" cmpd="sng" algn="ctr">
+                      <a:solidFill>
+                        <a:srgbClr val="D9DEE7"/>
+                      </a:solidFill>
+                      <a:prstDash val="solid"/>
+                      <a:round/>
+                      <a:headEnd type="none" w="med" len="med"/>
+                      <a:tailEnd type="none" w="med" len="med"/>
+                    </a:lnR>
+                    <a:lnT w="9525" cap="flat" cmpd="sng" algn="ctr">
+                      <a:solidFill>
+                        <a:srgbClr val="D9DEE7"/>
+                      </a:solidFill>
+                      <a:prstDash val="solid"/>
+                      <a:round/>
+                      <a:headEnd type="none" w="med" len="med"/>
+                      <a:tailEnd type="none" w="med" len="med"/>
+                    </a:lnT>
+                    <a:lnB w="9525" cap="flat" cmpd="sng" algn="ctr">
+                      <a:solidFill>
+                        <a:srgbClr val="D9DEE7"/>
+                      </a:solidFill>
+                      <a:prstDash val="solid"/>
+                      <a:round/>
+                      <a:headEnd type="none" w="med" len="med"/>
+                      <a:tailEnd type="none" w="med" len="med"/>
+                    </a:lnB>
+                  </a:tcPr>
+                </a:tc>
+                <a:tc>
+                  <a:txBody>
+                    <a:bodyPr/>
+                    <a:lstStyle/>
+                    <a:p>
+                      <a:pPr algn="r" indent="0" marL="0">
+                        <a:buNone/>
+                      </a:pPr>
+                      <a:r>
+                        <a:rPr lang="en-US" sz="1300" b="1" dirty="0">
+                          <a:solidFill>
+                            <a:srgbClr val="1D2330"/>
+                          </a:solidFill>
+                          <a:latin typeface="Calibri" pitchFamily="34" charset="0"/>
+                          <a:ea typeface="Calibri" pitchFamily="34" charset="-122"/>
+                          <a:cs typeface="Calibri" pitchFamily="34" charset="-120"/>
+                        </a:rPr>
+                        <a:t>$3,71</a:t>
+                      </a:r>
+                      <a:endParaRPr lang="en-US" sz="1300" dirty="0">
+                        <a:latin typeface="Calibri" charset="0"/>
+                        <a:ea typeface="Calibri" charset="0"/>
+                        <a:cs typeface="Calibri" charset="0"/>
+                      </a:endParaRPr>
+                    </a:p>
+                  </a:txBody>
+                  <a:tcPr marL="91440" marR="91440" marT="45720" marB="45720">
+                    <a:lnL w="9525" cap="flat" cmpd="sng" algn="ctr">
+                      <a:solidFill>
+                        <a:srgbClr val="D9DEE7"/>
+                      </a:solidFill>
+                      <a:prstDash val="solid"/>
+                      <a:round/>
+                      <a:headEnd type="none" w="med" len="med"/>
+                      <a:tailEnd type="none" w="med" len="med"/>
+                    </a:lnL>
+                    <a:lnR w="9525" cap="flat" cmpd="sng" algn="ctr">
+                      <a:solidFill>
+                        <a:srgbClr val="D9DEE7"/>
+                      </a:solidFill>
+                      <a:prstDash val="solid"/>
+                      <a:round/>
+                      <a:headEnd type="none" w="med" len="med"/>
+                      <a:tailEnd type="none" w="med" len="med"/>
+                    </a:lnR>
+                    <a:lnT w="9525" cap="flat" cmpd="sng" algn="ctr">
+                      <a:solidFill>
+                        <a:srgbClr val="D9DEE7"/>
+                      </a:solidFill>
+                      <a:prstDash val="solid"/>
+                      <a:round/>
+                      <a:headEnd type="none" w="med" len="med"/>
+                      <a:tailEnd type="none" w="med" len="med"/>
+                    </a:lnT>
+                    <a:lnB w="9525" cap="flat" cmpd="sng" algn="ctr">
+                      <a:solidFill>
+                        <a:srgbClr val="D9DEE7"/>
+                      </a:solidFill>
+                      <a:prstDash val="solid"/>
+                      <a:round/>
+                      <a:headEnd type="none" w="med" len="med"/>
+                      <a:tailEnd type="none" w="med" len="med"/>
+                    </a:lnB>
+                  </a:tcPr>
+                </a:tc>
+              </a:tr>
+              <a:tr h="384048">
+                <a:tc>
+                  <a:txBody>
+                    <a:bodyPr/>
+                    <a:lstStyle/>
+                    <a:p>
+                      <a:pPr indent="0" marL="0">
+                        <a:buNone/>
+                      </a:pPr>
+                      <a:r>
+                        <a:rPr lang="en-US" sz="1300" b="1" dirty="0">
+                          <a:solidFill>
+                            <a:srgbClr val="1D2330"/>
+                          </a:solidFill>
+                          <a:latin typeface="Calibri" pitchFamily="34" charset="0"/>
+                          <a:ea typeface="Calibri" pitchFamily="34" charset="-122"/>
+                          <a:cs typeface="Calibri" pitchFamily="34" charset="-120"/>
+                        </a:rPr>
+                        <a:t>Total</a:t>
+                      </a:r>
+                      <a:endParaRPr lang="en-US" sz="1300" dirty="0">
                         <a:latin typeface="Calibri" charset="0"/>
                         <a:ea typeface="Calibri" charset="0"/>
                         <a:cs typeface="Calibri" charset="0"/>
@@ -9144,85 +10167,7 @@
                       <a:pPr indent="0" marL="0">
                         <a:buNone/>
                       </a:pPr>
-                      <a:r>
-                        <a:rPr lang="en-US" sz="1350" b="1" dirty="0">
-                          <a:solidFill>
-                            <a:srgbClr val="1D2330"/>
-                          </a:solidFill>
-                          <a:latin typeface="Calibri" pitchFamily="34" charset="0"/>
-                          <a:ea typeface="Calibri" pitchFamily="34" charset="-122"/>
-                          <a:cs typeface="Calibri" pitchFamily="34" charset="-120"/>
-                        </a:rPr>
-                        <a:t>≈ 1 h 50 min</a:t>
-                      </a:r>
-                      <a:endParaRPr lang="en-US" sz="1350" dirty="0">
-                        <a:latin typeface="Calibri" charset="0"/>
-                        <a:ea typeface="Calibri" charset="0"/>
-                        <a:cs typeface="Calibri" charset="0"/>
-                      </a:endParaRPr>
-                    </a:p>
-                  </a:txBody>
-                  <a:tcPr marL="91440" marR="91440" marT="45720" marB="45720">
-                    <a:lnL w="9525" cap="flat" cmpd="sng" algn="ctr">
-                      <a:solidFill>
-                        <a:srgbClr val="D9DEE7"/>
-                      </a:solidFill>
-                      <a:prstDash val="solid"/>
-                      <a:round/>
-                      <a:headEnd type="none" w="med" len="med"/>
-                      <a:tailEnd type="none" w="med" len="med"/>
-                    </a:lnL>
-                    <a:lnR w="9525" cap="flat" cmpd="sng" algn="ctr">
-                      <a:solidFill>
-                        <a:srgbClr val="D9DEE7"/>
-                      </a:solidFill>
-                      <a:prstDash val="solid"/>
-                      <a:round/>
-                      <a:headEnd type="none" w="med" len="med"/>
-                      <a:tailEnd type="none" w="med" len="med"/>
-                    </a:lnR>
-                    <a:lnT w="9525" cap="flat" cmpd="sng" algn="ctr">
-                      <a:solidFill>
-                        <a:srgbClr val="D9DEE7"/>
-                      </a:solidFill>
-                      <a:prstDash val="solid"/>
-                      <a:round/>
-                      <a:headEnd type="none" w="med" len="med"/>
-                      <a:tailEnd type="none" w="med" len="med"/>
-                    </a:lnT>
-                    <a:lnB w="9525" cap="flat" cmpd="sng" algn="ctr">
-                      <a:solidFill>
-                        <a:srgbClr val="D9DEE7"/>
-                      </a:solidFill>
-                      <a:prstDash val="solid"/>
-                      <a:round/>
-                      <a:headEnd type="none" w="med" len="med"/>
-                      <a:tailEnd type="none" w="med" len="med"/>
-                    </a:lnB>
-                  </a:tcPr>
-                </a:tc>
-              </a:tr>
-              <a:tr h="393192">
-                <a:tc>
-                  <a:txBody>
-                    <a:bodyPr/>
-                    <a:lstStyle/>
-                    <a:p>
-                      <a:pPr indent="0" marL="0">
-                        <a:buNone/>
-                      </a:pPr>
-                      <a:r>
-                        <a:rPr lang="en-US" sz="1350" dirty="0">
-                          <a:solidFill>
-                            <a:srgbClr val="1D2330"/>
-                          </a:solidFill>
-                          <a:latin typeface="Calibri" pitchFamily="34" charset="0"/>
-                          <a:ea typeface="Calibri" pitchFamily="34" charset="-122"/>
-                          <a:cs typeface="Calibri" pitchFamily="34" charset="-120"/>
-                        </a:rPr>
-                        <a:t>Preguntas de aclaración al usuario</a:t>
-                      </a:r>
-                      <a:endParaRPr lang="en-US" sz="1350" dirty="0">
+                      <a:endParaRPr lang="en-US" sz="1300" dirty="0">
                         <a:latin typeface="Calibri" charset="0"/>
                         <a:ea typeface="Calibri" charset="0"/>
                         <a:cs typeface="Calibri" charset="0"/>
@@ -9276,18 +10221,7 @@
                       <a:pPr indent="0" marL="0">
                         <a:buNone/>
                       </a:pPr>
-                      <a:r>
-                        <a:rPr lang="en-US" sz="1350" b="1" dirty="0">
-                          <a:solidFill>
-                            <a:srgbClr val="1D2330"/>
-                          </a:solidFill>
-                          <a:latin typeface="Calibri" pitchFamily="34" charset="0"/>
-                          <a:ea typeface="Calibri" pitchFamily="34" charset="-122"/>
-                          <a:cs typeface="Calibri" pitchFamily="34" charset="-120"/>
-                        </a:rPr>
-                        <a:t>12 en 3 rondas</a:t>
-                      </a:r>
-                      <a:endParaRPr lang="en-US" sz="1350" dirty="0">
+                      <a:endParaRPr lang="en-US" sz="1300" dirty="0">
                         <a:latin typeface="Calibri" charset="0"/>
                         <a:ea typeface="Calibri" charset="0"/>
                         <a:cs typeface="Calibri" charset="0"/>
@@ -9333,28 +10267,26 @@
                     </a:lnB>
                   </a:tcPr>
                 </a:tc>
-              </a:tr>
-              <a:tr h="393192">
                 <a:tc>
                   <a:txBody>
                     <a:bodyPr/>
                     <a:lstStyle/>
                     <a:p>
-                      <a:pPr indent="0" marL="0">
+                      <a:pPr algn="r" indent="0" marL="0">
                         <a:buNone/>
                       </a:pPr>
                       <a:r>
-                        <a:rPr lang="en-US" sz="1350" dirty="0">
+                        <a:rPr lang="en-US" sz="1300" b="1" dirty="0">
                           <a:solidFill>
-                            <a:srgbClr val="1D2330"/>
+                            <a:srgbClr val="0B6E69"/>
                           </a:solidFill>
                           <a:latin typeface="Calibri" pitchFamily="34" charset="0"/>
                           <a:ea typeface="Calibri" pitchFamily="34" charset="-122"/>
                           <a:cs typeface="Calibri" pitchFamily="34" charset="-120"/>
                         </a:rPr>
-                        <a:t>Código C y scripts generados</a:t>
+                        <a:t>$22,67</a:t>
                       </a:r>
-                      <a:endParaRPr lang="en-US" sz="1350" dirty="0">
+                      <a:endParaRPr lang="en-US" sz="1300" dirty="0">
                         <a:latin typeface="Calibri" charset="0"/>
                         <a:ea typeface="Calibri" charset="0"/>
                         <a:cs typeface="Calibri" charset="0"/>
@@ -9400,472 +10332,135 @@
                     </a:lnB>
                   </a:tcPr>
                 </a:tc>
-                <a:tc>
-                  <a:txBody>
-                    <a:bodyPr/>
-                    <a:lstStyle/>
-                    <a:p>
-                      <a:pPr indent="0" marL="0">
-                        <a:buNone/>
-                      </a:pPr>
-                      <a:r>
-                        <a:rPr lang="en-US" sz="1350" b="1" dirty="0">
-                          <a:solidFill>
-                            <a:srgbClr val="1D2330"/>
-                          </a:solidFill>
-                          <a:latin typeface="Calibri" pitchFamily="34" charset="0"/>
-                          <a:ea typeface="Calibri" pitchFamily="34" charset="-122"/>
-                          <a:cs typeface="Calibri" pitchFamily="34" charset="-120"/>
-                        </a:rPr>
-                        <a:t>≈ 9.300 líneas · 38 ficheros en src/</a:t>
-                      </a:r>
-                      <a:endParaRPr lang="en-US" sz="1350" dirty="0">
-                        <a:latin typeface="Calibri" charset="0"/>
-                        <a:ea typeface="Calibri" charset="0"/>
-                        <a:cs typeface="Calibri" charset="0"/>
-                      </a:endParaRPr>
-                    </a:p>
-                  </a:txBody>
-                  <a:tcPr marL="91440" marR="91440" marT="45720" marB="45720">
-                    <a:lnL w="9525" cap="flat" cmpd="sng" algn="ctr">
-                      <a:solidFill>
-                        <a:srgbClr val="D9DEE7"/>
-                      </a:solidFill>
-                      <a:prstDash val="solid"/>
-                      <a:round/>
-                      <a:headEnd type="none" w="med" len="med"/>
-                      <a:tailEnd type="none" w="med" len="med"/>
-                    </a:lnL>
-                    <a:lnR w="9525" cap="flat" cmpd="sng" algn="ctr">
-                      <a:solidFill>
-                        <a:srgbClr val="D9DEE7"/>
-                      </a:solidFill>
-                      <a:prstDash val="solid"/>
-                      <a:round/>
-                      <a:headEnd type="none" w="med" len="med"/>
-                      <a:tailEnd type="none" w="med" len="med"/>
-                    </a:lnR>
-                    <a:lnT w="9525" cap="flat" cmpd="sng" algn="ctr">
-                      <a:solidFill>
-                        <a:srgbClr val="D9DEE7"/>
-                      </a:solidFill>
-                      <a:prstDash val="solid"/>
-                      <a:round/>
-                      <a:headEnd type="none" w="med" len="med"/>
-                      <a:tailEnd type="none" w="med" len="med"/>
-                    </a:lnT>
-                    <a:lnB w="9525" cap="flat" cmpd="sng" algn="ctr">
-                      <a:solidFill>
-                        <a:srgbClr val="D9DEE7"/>
-                      </a:solidFill>
-                      <a:prstDash val="solid"/>
-                      <a:round/>
-                      <a:headEnd type="none" w="med" len="med"/>
-                      <a:tailEnd type="none" w="med" len="med"/>
-                    </a:lnB>
-                  </a:tcPr>
-                </a:tc>
-              </a:tr>
-              <a:tr h="393192">
-                <a:tc>
-                  <a:txBody>
-                    <a:bodyPr/>
-                    <a:lstStyle/>
-                    <a:p>
-                      <a:pPr indent="0" marL="0">
-                        <a:buNone/>
-                      </a:pPr>
-                      <a:r>
-                        <a:rPr lang="en-US" sz="1350" dirty="0">
-                          <a:solidFill>
-                            <a:srgbClr val="1D2330"/>
-                          </a:solidFill>
-                          <a:latin typeface="Calibri" pitchFamily="34" charset="0"/>
-                          <a:ea typeface="Calibri" pitchFamily="34" charset="-122"/>
-                          <a:cs typeface="Calibri" pitchFamily="34" charset="-120"/>
-                        </a:rPr>
-                        <a:t>Documentación</a:t>
-                      </a:r>
-                      <a:endParaRPr lang="en-US" sz="1350" dirty="0">
-                        <a:latin typeface="Calibri" charset="0"/>
-                        <a:ea typeface="Calibri" charset="0"/>
-                        <a:cs typeface="Calibri" charset="0"/>
-                      </a:endParaRPr>
-                    </a:p>
-                  </a:txBody>
-                  <a:tcPr marL="91440" marR="91440" marT="45720" marB="45720">
-                    <a:lnL w="9525" cap="flat" cmpd="sng" algn="ctr">
-                      <a:solidFill>
-                        <a:srgbClr val="D9DEE7"/>
-                      </a:solidFill>
-                      <a:prstDash val="solid"/>
-                      <a:round/>
-                      <a:headEnd type="none" w="med" len="med"/>
-                      <a:tailEnd type="none" w="med" len="med"/>
-                    </a:lnL>
-                    <a:lnR w="9525" cap="flat" cmpd="sng" algn="ctr">
-                      <a:solidFill>
-                        <a:srgbClr val="D9DEE7"/>
-                      </a:solidFill>
-                      <a:prstDash val="solid"/>
-                      <a:round/>
-                      <a:headEnd type="none" w="med" len="med"/>
-                      <a:tailEnd type="none" w="med" len="med"/>
-                    </a:lnR>
-                    <a:lnT w="9525" cap="flat" cmpd="sng" algn="ctr">
-                      <a:solidFill>
-                        <a:srgbClr val="D9DEE7"/>
-                      </a:solidFill>
-                      <a:prstDash val="solid"/>
-                      <a:round/>
-                      <a:headEnd type="none" w="med" len="med"/>
-                      <a:tailEnd type="none" w="med" len="med"/>
-                    </a:lnT>
-                    <a:lnB w="9525" cap="flat" cmpd="sng" algn="ctr">
-                      <a:solidFill>
-                        <a:srgbClr val="D9DEE7"/>
-                      </a:solidFill>
-                      <a:prstDash val="solid"/>
-                      <a:round/>
-                      <a:headEnd type="none" w="med" len="med"/>
-                      <a:tailEnd type="none" w="med" len="med"/>
-                    </a:lnB>
-                  </a:tcPr>
-                </a:tc>
-                <a:tc>
-                  <a:txBody>
-                    <a:bodyPr/>
-                    <a:lstStyle/>
-                    <a:p>
-                      <a:pPr indent="0" marL="0">
-                        <a:buNone/>
-                      </a:pPr>
-                      <a:r>
-                        <a:rPr lang="en-US" sz="1350" b="1" dirty="0">
-                          <a:solidFill>
-                            <a:srgbClr val="1D2330"/>
-                          </a:solidFill>
-                          <a:latin typeface="Calibri" pitchFamily="34" charset="0"/>
-                          <a:ea typeface="Calibri" pitchFamily="34" charset="-122"/>
-                          <a:cs typeface="Calibri" pitchFamily="34" charset="-120"/>
-                        </a:rPr>
-                        <a:t>SPEC, requerimientos, decisiones, verificación, 2 PDF, esta presentación</a:t>
-                      </a:r>
-                      <a:endParaRPr lang="en-US" sz="1350" dirty="0">
-                        <a:latin typeface="Calibri" charset="0"/>
-                        <a:ea typeface="Calibri" charset="0"/>
-                        <a:cs typeface="Calibri" charset="0"/>
-                      </a:endParaRPr>
-                    </a:p>
-                  </a:txBody>
-                  <a:tcPr marL="91440" marR="91440" marT="45720" marB="45720">
-                    <a:lnL w="9525" cap="flat" cmpd="sng" algn="ctr">
-                      <a:solidFill>
-                        <a:srgbClr val="D9DEE7"/>
-                      </a:solidFill>
-                      <a:prstDash val="solid"/>
-                      <a:round/>
-                      <a:headEnd type="none" w="med" len="med"/>
-                      <a:tailEnd type="none" w="med" len="med"/>
-                    </a:lnL>
-                    <a:lnR w="9525" cap="flat" cmpd="sng" algn="ctr">
-                      <a:solidFill>
-                        <a:srgbClr val="D9DEE7"/>
-                      </a:solidFill>
-                      <a:prstDash val="solid"/>
-                      <a:round/>
-                      <a:headEnd type="none" w="med" len="med"/>
-                      <a:tailEnd type="none" w="med" len="med"/>
-                    </a:lnR>
-                    <a:lnT w="9525" cap="flat" cmpd="sng" algn="ctr">
-                      <a:solidFill>
-                        <a:srgbClr val="D9DEE7"/>
-                      </a:solidFill>
-                      <a:prstDash val="solid"/>
-                      <a:round/>
-                      <a:headEnd type="none" w="med" len="med"/>
-                      <a:tailEnd type="none" w="med" len="med"/>
-                    </a:lnT>
-                    <a:lnB w="9525" cap="flat" cmpd="sng" algn="ctr">
-                      <a:solidFill>
-                        <a:srgbClr val="D9DEE7"/>
-                      </a:solidFill>
-                      <a:prstDash val="solid"/>
-                      <a:round/>
-                      <a:headEnd type="none" w="med" len="med"/>
-                      <a:tailEnd type="none" w="med" len="med"/>
-                    </a:lnB>
-                  </a:tcPr>
-                </a:tc>
-              </a:tr>
-              <a:tr h="393192">
-                <a:tc>
-                  <a:txBody>
-                    <a:bodyPr/>
-                    <a:lstStyle/>
-                    <a:p>
-                      <a:pPr indent="0" marL="0">
-                        <a:buNone/>
-                      </a:pPr>
-                      <a:r>
-                        <a:rPr lang="en-US" sz="1350" dirty="0">
-                          <a:solidFill>
-                            <a:srgbClr val="1D2330"/>
-                          </a:solidFill>
-                          <a:latin typeface="Calibri" pitchFamily="34" charset="0"/>
-                          <a:ea typeface="Calibri" pitchFamily="34" charset="-122"/>
-                          <a:cs typeface="Calibri" pitchFamily="34" charset="-120"/>
-                        </a:rPr>
-                        <a:t>Iteraciones de prueba hasta el verde</a:t>
-                      </a:r>
-                      <a:endParaRPr lang="en-US" sz="1350" dirty="0">
-                        <a:latin typeface="Calibri" charset="0"/>
-                        <a:ea typeface="Calibri" charset="0"/>
-                        <a:cs typeface="Calibri" charset="0"/>
-                      </a:endParaRPr>
-                    </a:p>
-                  </a:txBody>
-                  <a:tcPr marL="91440" marR="91440" marT="45720" marB="45720">
-                    <a:lnL w="9525" cap="flat" cmpd="sng" algn="ctr">
-                      <a:solidFill>
-                        <a:srgbClr val="D9DEE7"/>
-                      </a:solidFill>
-                      <a:prstDash val="solid"/>
-                      <a:round/>
-                      <a:headEnd type="none" w="med" len="med"/>
-                      <a:tailEnd type="none" w="med" len="med"/>
-                    </a:lnL>
-                    <a:lnR w="9525" cap="flat" cmpd="sng" algn="ctr">
-                      <a:solidFill>
-                        <a:srgbClr val="D9DEE7"/>
-                      </a:solidFill>
-                      <a:prstDash val="solid"/>
-                      <a:round/>
-                      <a:headEnd type="none" w="med" len="med"/>
-                      <a:tailEnd type="none" w="med" len="med"/>
-                    </a:lnR>
-                    <a:lnT w="9525" cap="flat" cmpd="sng" algn="ctr">
-                      <a:solidFill>
-                        <a:srgbClr val="D9DEE7"/>
-                      </a:solidFill>
-                      <a:prstDash val="solid"/>
-                      <a:round/>
-                      <a:headEnd type="none" w="med" len="med"/>
-                      <a:tailEnd type="none" w="med" len="med"/>
-                    </a:lnT>
-                    <a:lnB w="9525" cap="flat" cmpd="sng" algn="ctr">
-                      <a:solidFill>
-                        <a:srgbClr val="D9DEE7"/>
-                      </a:solidFill>
-                      <a:prstDash val="solid"/>
-                      <a:round/>
-                      <a:headEnd type="none" w="med" len="med"/>
-                      <a:tailEnd type="none" w="med" len="med"/>
-                    </a:lnB>
-                  </a:tcPr>
-                </a:tc>
-                <a:tc>
-                  <a:txBody>
-                    <a:bodyPr/>
-                    <a:lstStyle/>
-                    <a:p>
-                      <a:pPr indent="0" marL="0">
-                        <a:buNone/>
-                      </a:pPr>
-                      <a:r>
-                        <a:rPr lang="en-US" sz="1350" b="1" dirty="0">
-                          <a:solidFill>
-                            <a:srgbClr val="1D2330"/>
-                          </a:solidFill>
-                          <a:latin typeface="Calibri" pitchFamily="34" charset="0"/>
-                          <a:ea typeface="Calibri" pitchFamily="34" charset="-122"/>
-                          <a:cs typeface="Calibri" pitchFamily="34" charset="-120"/>
-                        </a:rPr>
-                        <a:t>1.ª ejecución 86/93 → 96/96; 3 bugs reales corregidos</a:t>
-                      </a:r>
-                      <a:endParaRPr lang="en-US" sz="1350" dirty="0">
-                        <a:latin typeface="Calibri" charset="0"/>
-                        <a:ea typeface="Calibri" charset="0"/>
-                        <a:cs typeface="Calibri" charset="0"/>
-                      </a:endParaRPr>
-                    </a:p>
-                  </a:txBody>
-                  <a:tcPr marL="91440" marR="91440" marT="45720" marB="45720">
-                    <a:lnL w="9525" cap="flat" cmpd="sng" algn="ctr">
-                      <a:solidFill>
-                        <a:srgbClr val="D9DEE7"/>
-                      </a:solidFill>
-                      <a:prstDash val="solid"/>
-                      <a:round/>
-                      <a:headEnd type="none" w="med" len="med"/>
-                      <a:tailEnd type="none" w="med" len="med"/>
-                    </a:lnL>
-                    <a:lnR w="9525" cap="flat" cmpd="sng" algn="ctr">
-                      <a:solidFill>
-                        <a:srgbClr val="D9DEE7"/>
-                      </a:solidFill>
-                      <a:prstDash val="solid"/>
-                      <a:round/>
-                      <a:headEnd type="none" w="med" len="med"/>
-                      <a:tailEnd type="none" w="med" len="med"/>
-                    </a:lnR>
-                    <a:lnT w="9525" cap="flat" cmpd="sng" algn="ctr">
-                      <a:solidFill>
-                        <a:srgbClr val="D9DEE7"/>
-                      </a:solidFill>
-                      <a:prstDash val="solid"/>
-                      <a:round/>
-                      <a:headEnd type="none" w="med" len="med"/>
-                      <a:tailEnd type="none" w="med" len="med"/>
-                    </a:lnT>
-                    <a:lnB w="9525" cap="flat" cmpd="sng" algn="ctr">
-                      <a:solidFill>
-                        <a:srgbClr val="D9DEE7"/>
-                      </a:solidFill>
-                      <a:prstDash val="solid"/>
-                      <a:round/>
-                      <a:headEnd type="none" w="med" len="med"/>
-                      <a:tailEnd type="none" w="med" len="med"/>
-                    </a:lnB>
-                  </a:tcPr>
-                </a:tc>
-              </a:tr>
-              <a:tr h="393192">
-                <a:tc>
-                  <a:txBody>
-                    <a:bodyPr/>
-                    <a:lstStyle/>
-                    <a:p>
-                      <a:pPr indent="0" marL="0">
-                        <a:buNone/>
-                      </a:pPr>
-                      <a:r>
-                        <a:rPr lang="en-US" sz="1350" dirty="0">
-                          <a:solidFill>
-                            <a:srgbClr val="1D2330"/>
-                          </a:solidFill>
-                          <a:latin typeface="Calibri" pitchFamily="34" charset="0"/>
-                          <a:ea typeface="Calibri" pitchFamily="34" charset="-122"/>
-                          <a:cs typeface="Calibri" pitchFamily="34" charset="-120"/>
-                        </a:rPr>
-                        <a:t>Intervención humana</a:t>
-                      </a:r>
-                      <a:endParaRPr lang="en-US" sz="1350" dirty="0">
-                        <a:latin typeface="Calibri" charset="0"/>
-                        <a:ea typeface="Calibri" charset="0"/>
-                        <a:cs typeface="Calibri" charset="0"/>
-                      </a:endParaRPr>
-                    </a:p>
-                  </a:txBody>
-                  <a:tcPr marL="91440" marR="91440" marT="45720" marB="45720">
-                    <a:lnL w="9525" cap="flat" cmpd="sng" algn="ctr">
-                      <a:solidFill>
-                        <a:srgbClr val="D9DEE7"/>
-                      </a:solidFill>
-                      <a:prstDash val="solid"/>
-                      <a:round/>
-                      <a:headEnd type="none" w="med" len="med"/>
-                      <a:tailEnd type="none" w="med" len="med"/>
-                    </a:lnL>
-                    <a:lnR w="9525" cap="flat" cmpd="sng" algn="ctr">
-                      <a:solidFill>
-                        <a:srgbClr val="D9DEE7"/>
-                      </a:solidFill>
-                      <a:prstDash val="solid"/>
-                      <a:round/>
-                      <a:headEnd type="none" w="med" len="med"/>
-                      <a:tailEnd type="none" w="med" len="med"/>
-                    </a:lnR>
-                    <a:lnT w="9525" cap="flat" cmpd="sng" algn="ctr">
-                      <a:solidFill>
-                        <a:srgbClr val="D9DEE7"/>
-                      </a:solidFill>
-                      <a:prstDash val="solid"/>
-                      <a:round/>
-                      <a:headEnd type="none" w="med" len="med"/>
-                      <a:tailEnd type="none" w="med" len="med"/>
-                    </a:lnT>
-                    <a:lnB w="9525" cap="flat" cmpd="sng" algn="ctr">
-                      <a:solidFill>
-                        <a:srgbClr val="D9DEE7"/>
-                      </a:solidFill>
-                      <a:prstDash val="solid"/>
-                      <a:round/>
-                      <a:headEnd type="none" w="med" len="med"/>
-                      <a:tailEnd type="none" w="med" len="med"/>
-                    </a:lnB>
-                  </a:tcPr>
-                </a:tc>
-                <a:tc>
-                  <a:txBody>
-                    <a:bodyPr/>
-                    <a:lstStyle/>
-                    <a:p>
-                      <a:pPr indent="0" marL="0">
-                        <a:buNone/>
-                      </a:pPr>
-                      <a:r>
-                        <a:rPr lang="en-US" sz="1350" b="1" dirty="0">
-                          <a:solidFill>
-                            <a:srgbClr val="1D2330"/>
-                          </a:solidFill>
-                          <a:latin typeface="Calibri" pitchFamily="34" charset="0"/>
-                          <a:ea typeface="Calibri" pitchFamily="34" charset="-122"/>
-                          <a:cs typeface="Calibri" pitchFamily="34" charset="-120"/>
-                        </a:rPr>
-                        <a:t>instalar dependencias (sudo) y autenticarse en GitLab</a:t>
-                      </a:r>
-                      <a:endParaRPr lang="en-US" sz="1350" dirty="0">
-                        <a:latin typeface="Calibri" charset="0"/>
-                        <a:ea typeface="Calibri" charset="0"/>
-                        <a:cs typeface="Calibri" charset="0"/>
-                      </a:endParaRPr>
-                    </a:p>
-                  </a:txBody>
-                  <a:tcPr marL="91440" marR="91440" marT="45720" marB="45720">
-                    <a:lnL w="9525" cap="flat" cmpd="sng" algn="ctr">
-                      <a:solidFill>
-                        <a:srgbClr val="D9DEE7"/>
-                      </a:solidFill>
-                      <a:prstDash val="solid"/>
-                      <a:round/>
-                      <a:headEnd type="none" w="med" len="med"/>
-                      <a:tailEnd type="none" w="med" len="med"/>
-                    </a:lnL>
-                    <a:lnR w="9525" cap="flat" cmpd="sng" algn="ctr">
-                      <a:solidFill>
-                        <a:srgbClr val="D9DEE7"/>
-                      </a:solidFill>
-                      <a:prstDash val="solid"/>
-                      <a:round/>
-                      <a:headEnd type="none" w="med" len="med"/>
-                      <a:tailEnd type="none" w="med" len="med"/>
-                    </a:lnR>
-                    <a:lnT w="9525" cap="flat" cmpd="sng" algn="ctr">
-                      <a:solidFill>
-                        <a:srgbClr val="D9DEE7"/>
-                      </a:solidFill>
-                      <a:prstDash val="solid"/>
-                      <a:round/>
-                      <a:headEnd type="none" w="med" len="med"/>
-                      <a:tailEnd type="none" w="med" len="med"/>
-                    </a:lnT>
-                    <a:lnB w="9525" cap="flat" cmpd="sng" algn="ctr">
-                      <a:solidFill>
-                        <a:srgbClr val="D9DEE7"/>
-                      </a:solidFill>
-                      <a:prstDash val="solid"/>
-                      <a:round/>
-                      <a:headEnd type="none" w="med" len="med"/>
-                      <a:tailEnd type="none" w="med" len="med"/>
-                    </a:lnB>
-                  </a:tcPr>
-                </a:tc>
               </a:tr>
             </a:tbl>
           </a:graphicData>
         </a:graphic>
       </p:graphicFrame>
+      <p:sp>
+        <p:nvSpPr>
+          <p:cNvPr id="21" name="Text 18"/>
+          <p:cNvSpPr/>
+          <p:nvPr/>
+        </p:nvSpPr>
+        <p:spPr>
+          <a:xfrm>
+            <a:off x="7589520" y="3154680"/>
+            <a:ext cx="4069080" cy="3017520"/>
+          </a:xfrm>
+          <a:prstGeom prst="rect">
+            <a:avLst/>
+          </a:prstGeom>
+          <a:noFill/>
+          <a:ln/>
+        </p:spPr>
+        <p:txBody>
+          <a:bodyPr wrap="square" rtlCol="0" anchor="t"/>
+          <a:lstStyle/>
+          <a:p>
+            <a:pPr indent="0" marL="0">
+              <a:buNone/>
+            </a:pPr>
+            <a:r>
+              <a:rPr lang="en-US" sz="1400" b="1" dirty="0">
+                <a:solidFill>
+                  <a:srgbClr val="1D2330"/>
+                </a:solidFill>
+                <a:latin typeface="Calibri" pitchFamily="34" charset="0"/>
+                <a:ea typeface="Calibri" pitchFamily="34" charset="-122"/>
+                <a:cs typeface="Calibri" pitchFamily="34" charset="-120"/>
+              </a:rPr>
+              <a:t>Qué se obtuvo por ese coste</a:t>
+            </a:r>
+            <a:endParaRPr lang="en-US" sz="1400" dirty="0"/>
+          </a:p>
+          <a:p>
+            <a:pPr indent="0" marL="0">
+              <a:buNone/>
+            </a:pPr>
+            <a:r>
+              <a:rPr lang="en-US" sz="1400" dirty="0">
+                <a:solidFill>
+                  <a:srgbClr val="1D2330"/>
+                </a:solidFill>
+                <a:latin typeface="Calibri" pitchFamily="34" charset="0"/>
+                <a:ea typeface="Calibri" pitchFamily="34" charset="-122"/>
+                <a:cs typeface="Calibri" pitchFamily="34" charset="-120"/>
+              </a:rPr>
+              <a:t>≈ 9.300 líneas de C y scripts, 127 pruebas, benchmark, 2 PDF, esta presentación, MR y repo publicado.</a:t>
+            </a:r>
+            <a:endParaRPr lang="en-US" sz="1400" dirty="0"/>
+          </a:p>
+          <a:p>
+            <a:pPr indent="0" marL="0">
+              <a:buNone/>
+            </a:pPr>
+            <a:r>
+              <a:rPr lang="en-US" sz="600" dirty="0">
+                <a:solidFill>
+                  <a:srgbClr val="1D2330"/>
+                </a:solidFill>
+                <a:latin typeface="Calibri" pitchFamily="34" charset="0"/>
+                <a:ea typeface="Calibri" pitchFamily="34" charset="-122"/>
+                <a:cs typeface="Calibri" pitchFamily="34" charset="-120"/>
+              </a:rPr>
+              <a:t> </a:t>
+            </a:r>
+            <a:endParaRPr lang="en-US" sz="1400" dirty="0"/>
+          </a:p>
+          <a:p>
+            <a:pPr indent="0" marL="0">
+              <a:buNone/>
+            </a:pPr>
+            <a:r>
+              <a:rPr lang="en-US" sz="1200" dirty="0">
+                <a:solidFill>
+                  <a:srgbClr val="5B6475"/>
+                </a:solidFill>
+                <a:latin typeface="Calibri" pitchFamily="34" charset="0"/>
+                <a:ea typeface="Calibri" pitchFamily="34" charset="-122"/>
+                <a:cs typeface="Calibri" pitchFamily="34" charset="-120"/>
+              </a:rPr>
+              <a:t>Intervención humana: 12 respuestas de diseño, instalar dependencias (sudo) y autenticarse en GitLab/GitHub.</a:t>
+            </a:r>
+            <a:endParaRPr lang="en-US" sz="1400" dirty="0"/>
+          </a:p>
+          <a:p>
+            <a:pPr indent="0" marL="0">
+              <a:buNone/>
+            </a:pPr>
+            <a:r>
+              <a:rPr lang="en-US" sz="600" dirty="0">
+                <a:solidFill>
+                  <a:srgbClr val="1D2330"/>
+                </a:solidFill>
+                <a:latin typeface="Calibri" pitchFamily="34" charset="0"/>
+                <a:ea typeface="Calibri" pitchFamily="34" charset="-122"/>
+                <a:cs typeface="Calibri" pitchFamily="34" charset="-120"/>
+              </a:rPr>
+              <a:t> </a:t>
+            </a:r>
+            <a:endParaRPr lang="en-US" sz="1400" dirty="0"/>
+          </a:p>
+          <a:p>
+            <a:pPr indent="0" marL="0">
+              <a:buNone/>
+            </a:pPr>
+            <a:r>
+              <a:rPr lang="en-US" sz="1200" i="1" dirty="0">
+                <a:solidFill>
+                  <a:srgbClr val="9A5B00"/>
+                </a:solidFill>
+                <a:latin typeface="Calibri" pitchFamily="34" charset="0"/>
+                <a:ea typeface="Calibri" pitchFamily="34" charset="-122"/>
+                <a:cs typeface="Calibri" pitchFamily="34" charset="-120"/>
+              </a:rPr>
+              <a:t>Con plan Claude Max no se factura por token: la cifra es la referencia a precios de API.</a:t>
+            </a:r>
+            <a:endParaRPr lang="en-US" sz="1400" dirty="0"/>
+          </a:p>
+        </p:txBody>
+      </p:sp>
       <p:sp>
         <p:nvSpPr>
           <p:cNvPr id="25" name="Slide Number Placeholder 0"/>

</xml_diff>